<commit_message>
pre-submission: fix prose overclaims and arithmetic per adversarial review; add supplementary metrics; finalize report
Co-Authored-By: Claude Opus 4.6 (1M context) <noreply@anthropic.com>
</commit_message>
<xml_diff>
--- a/report/slides.pptx
+++ b/report/slides.pptx
@@ -3090,7 +3090,7 @@
                 <a:ea typeface="Cambria" pitchFamily="34" charset="-122"/>
                 <a:cs typeface="Cambria" pitchFamily="34" charset="-120"/>
               </a:rPr>
-              <a:t>Results: no model gets better — most get worse</a:t>
+              <a:t>Results — NLI, the headline task</a:t>
             </a:r>
             <a:endParaRPr lang="en-US" sz="3200" dirty="0"/>
           </a:p>
@@ -5621,7 +5621,7 @@
                   <a:srgbClr val="1E2761"/>
                 </a:solidFill>
               </a:rPr>
-              <a:t>Raw Hebrew is the best input condition for every model, on nearly every task.</a:t>
+              <a:t>No intervention ever significantly beats raw Hebrew — for any model, on any task.</a:t>
             </a:r>
             <a:endParaRPr lang="en-US" sz="2000" dirty="0"/>
           </a:p>
@@ -6102,7 +6102,7 @@
                   <a:srgbClr val="1E2761"/>
                 </a:solidFill>
               </a:rPr>
-              <a:t>Correct answer, segmented spelling → scored wrong. ~80% of the “collapse” was this artifact; the real drop is 3–5 points.</a:t>
+              <a:t>Correct answer, segmented spelling → scored wrong. After correction, the drop is significant for only 2 of 4 models.</a:t>
             </a:r>
             <a:endParaRPr lang="en-US" sz="1700" dirty="0"/>
           </a:p>
@@ -6494,7 +6494,7 @@
                   <a:srgbClr val="1A1A2E"/>
                 </a:solidFill>
               </a:rPr>
-              <a:t>manipulated input made the model think 5× longer — segmentation raises processing effort even when accuracy survives.</a:t>
+              <a:t>manipulated input produced ~5× more budget-exhausted responses — evidence of extra processing effort even when accuracy survives.</a:t>
             </a:r>
             <a:endParaRPr lang="en-US" sz="1600" dirty="0"/>
           </a:p>
@@ -6715,7 +6715,7 @@
                   <a:srgbClr val="1A1A2E"/>
                 </a:solidFill>
               </a:rPr>
-              <a:t>Segmented input is 12–20% longer: more compute and API cost for worse accuracy.</a:t>
+              <a:t>Segmented input is 6–18% longer: more compute and API cost for no benefit.</a:t>
             </a:r>
             <a:endParaRPr lang="en-US" sz="1800" dirty="0"/>
           </a:p>
@@ -7349,7 +7349,7 @@
                   <a:srgbClr val="CADCFC"/>
                 </a:solidFill>
               </a:rPr>
-              <a:t>Segmentation never helps — and significantly hurts NLI (3/4 models) and QA (4/4).</a:t>
+              <a:t>Segmentation never helps — significantly hurts NLI (3/4 models) and strict-EM QA (4/4; 2/4 after artifact correction).</a:t>
             </a:r>
             <a:endParaRPr lang="en-US" sz="1800" dirty="0"/>
           </a:p>
@@ -7367,7 +7367,7 @@
                   <a:srgbClr val="CADCFC"/>
                 </a:solidFill>
               </a:rPr>
-              <a:t>Prompting about morphology can’t substitute: null for frontier models, harmful for small ones.</a:t>
+              <a:t>Prompting about morphology can’t substitute: never helps, and significantly harms GPT-4o, Mistral (NLI) and LLaMA (NLI+QA).</a:t>
             </a:r>
             <a:endParaRPr lang="en-US" sz="1800" dirty="0"/>
           </a:p>
@@ -7385,7 +7385,7 @@
                   <a:srgbClr val="CADCFC"/>
                 </a:solidFill>
               </a:rPr>
-              <a:t>Mechanism: subword tokenizers already segment; explicit morphology = distribution shift + 12–20% extra cost.</a:t>
+              <a:t>Mechanism: subword tokenizers already segment; explicit morphology = distribution shift + 6–18% extra cost.</a:t>
             </a:r>
             <a:endParaRPr lang="en-US" sz="1800" dirty="0"/>
           </a:p>
@@ -7403,7 +7403,7 @@
                   <a:srgbClr val="CADCFC"/>
                 </a:solidFill>
               </a:rPr>
-              <a:t>Hint for future work: small models on sentiment trended positive (not significant).</a:t>
+              <a:t>Cautionary aside: LLaMA’s small sentiment accuracy gains coincide with falling macro-F1 — likely majority-class drift, not improvement.</a:t>
             </a:r>
             <a:endParaRPr lang="en-US" sz="1800" dirty="0"/>
           </a:p>
@@ -7418,7 +7418,7 @@
                   <a:srgbClr val="FFFFFF"/>
                 </a:solidFill>
               </a:rPr>
-              <a:t>Preprocessing wisdom from the statistical era does not transfer to LLMs — “helping” them with linguistic structure can hurt, distort evaluation, and raise reasoning effort.</a:t>
+              <a:t>Preprocessing wisdom from the statistical era does not transfer to LLMs — “helping” them with linguistic structure can hurt, distort evaluation, and increase processing effort.</a:t>
             </a:r>
             <a:endParaRPr lang="en-US" sz="1800" dirty="0"/>
           </a:p>

</xml_diff>